<commit_message>
clarifica división de trabajo en integración de IA
- 1.5, PPT y guion: distingue explícitamente el rol de Benjamín
  (orquestación de la API de IA) del rol de Sergio (contexto de
  datos y almacenamiento de resultados), evitando ambigüedad
  sobre "quién hace la IA"
- Plan de Trabajo: agrega a Benjamín como responsable de la fila
  "Módulo de IA y botón de asistencia"
</commit_message>
<xml_diff>
--- a/Fase 1/Evidencias Grupales/PerfilMedico_ExposicionFase1.pptx
+++ b/Fase 1/Evidencias Grupales/PerfilMedico_ExposicionFase1.pptx
@@ -4858,7 +4858,7 @@
                 <a:ea typeface="Calibri" pitchFamily="34" charset="-122"/>
                 <a:cs typeface="Calibri" pitchFamily="34" charset="-120"/>
               </a:rPr>
-              <a:t>API REST, autenticación JWT, lógica de negocio, integración de notificaciones e IA</a:t>
+              <a:t>API REST, autenticación JWT, lógica de negocio, orquestación de la API de IA (consultas y manejo de errores) e integración de notificaciones</a:t>
             </a:r>
             <a:endParaRPr lang="en-US" sz="1150" dirty="0"/>
           </a:p>
@@ -5093,7 +5093,7 @@
                 <a:ea typeface="Calibri" pitchFamily="34" charset="-122"/>
                 <a:cs typeface="Calibri" pitchFamily="34" charset="-120"/>
               </a:rPr>
-              <a:t>Modelado de BD, indicadores y reportes de cumplimiento, integración del módulo de IA</a:t>
+              <a:t>Modelado de BD, indicadores y reportes de cumplimiento, define el contexto enviado a la IA y almacena sus resultados</a:t>
             </a:r>
             <a:endParaRPr lang="en-US" sz="1150" dirty="0"/>
           </a:p>
@@ -14226,7 +14226,7 @@
                 <a:ea typeface="Calibri" pitchFamily="34" charset="-122"/>
                 <a:cs typeface="Calibri" pitchFamily="34" charset="-120"/>
               </a:rPr>
-              <a:t>Diseñar y estructurar la base de datos en PostgreSQL, junto con integrar el módulo de IA, refleja directamente mi interés en el modelado de datos y en la resolución práctica de problemas con inteligencia artificial. Me proyecto en ingeniería y gestión de datos.</a:t>
+              <a:t>Diseñar y estructurar la base de datos en PostgreSQL, definiendo qué datos sirven de contexto para el módulo de IA y cómo se almacenan sus resultados, refleja directamente mi interés en el modelado de datos y en la resolución práctica de problemas con inteligencia artificial. Me proyecto en ingeniería y gestión de datos.</a:t>
             </a:r>
             <a:endParaRPr lang="en-US" sz="1150" dirty="0"/>
           </a:p>

</xml_diff>